<commit_message>
research(results): trained unconditional FID 3.24 = H4 -> FID does not credit conditioning; oracle-text CFG-sweep evals
- Rung 1 definitive (ego-zeroed eval, CFG 1, 3 reps, gt_Div 5.496 PASS):
  ep4999 3.241+-0.130, ep4499 4.068, ep3999 4.904. Indistinguishable from
  H4 (3.392+-0.179); the paper's ego-zeroed prior (5.18) was a weak null
  branch. Paper: new tab:trivial row + paragraph routing the conditioning
  claim through ADE/FDE + behavioral probe. One-pager regenerated.
- Oracle text run complete: best train-val 2.70 @ep3099; definitive eval
  as a CFG sweep {1,2.5,5,10} (fair vehicle-only run flat ~5.6 at CFG 10,
  worse than unconditional -> CFG amplification of a weak condition).
- helma eval logs archived under research/data/helma_eval_logs/.

Co-Authored-By: Claude Fable 5.1 <noreply@anthropic.com>
</commit_message>
<xml_diff>
--- a/research/to_human/EgoPed_onepager.pptx
+++ b/research/to_human/EgoPed_onepager.pptx
@@ -5372,7 +5372,7 @@
         </p:nvGraphicFramePr>
         <p:xfrm>
           <a:off x="6446520" y="3090672"/>
-          <a:ext cx="5422391" cy="1504188"/>
+          <a:ext cx="5422391" cy="1719072"/>
         </p:xfrm>
         <a:graphic>
           <a:graphicData uri="http://schemas.openxmlformats.org/drawingml/2006/table">
@@ -5541,7 +5541,7 @@
                           </a:solidFill>
                           <a:latin typeface="Calibri"/>
                         </a:rPr>
-                        <a:t>Unconditional prior</a:t>
+                        <a:t>Unconditional, properly trained</a:t>
                       </a:r>
                     </a:p>
                   </a:txBody>
@@ -5564,7 +5564,7 @@
                           </a:solidFill>
                           <a:latin typeface="Calibri"/>
                         </a:rPr>
-                        <a:t>5.18</a:t>
+                        <a:t>3.24</a:t>
                       </a:r>
                     </a:p>
                   </a:txBody>
@@ -5587,7 +5587,7 @@
                           </a:solidFill>
                           <a:latin typeface="Calibri"/>
                         </a:rPr>
-                        <a:t>conditioning worth 34%</a:t>
+                        <a:t>≈ H4 — FID is blind to conditioning</a:t>
                       </a:r>
                     </a:p>
                   </a:txBody>
@@ -5612,7 +5612,7 @@
                           </a:solidFill>
                           <a:latin typeface="Calibri"/>
                         </a:rPr>
-                        <a:t>Pretrained text-to-motion MLD</a:t>
+                        <a:t>Unconditional prior (ego zeroed)</a:t>
                       </a:r>
                     </a:p>
                   </a:txBody>
@@ -5635,7 +5635,7 @@
                           </a:solidFill>
                           <a:latin typeface="Calibri"/>
                         </a:rPr>
-                        <a:t>14.07</a:t>
+                        <a:t>5.18</a:t>
                       </a:r>
                     </a:p>
                   </a:txBody>
@@ -5658,7 +5658,7 @@
                           </a:solidFill>
                           <a:latin typeface="Calibri"/>
                         </a:rPr>
-                        <a:t>T2M does not transfer</a:t>
+                        <a:t>a weak null branch, not a prior</a:t>
                       </a:r>
                     </a:p>
                   </a:txBody>
@@ -5683,7 +5683,7 @@
                           </a:solidFill>
                           <a:latin typeface="Calibri"/>
                         </a:rPr>
-                        <a:t>Raw-space diffusion (MDM-style)</a:t>
+                        <a:t>Pretrained text-to-motion MLD</a:t>
                       </a:r>
                     </a:p>
                   </a:txBody>
@@ -5706,7 +5706,7 @@
                           </a:solidFill>
                           <a:latin typeface="Calibri"/>
                         </a:rPr>
-                        <a:t>26.43</a:t>
+                        <a:t>14.07</a:t>
                       </a:r>
                     </a:p>
                   </a:txBody>
@@ -5729,7 +5729,7 @@
                           </a:solidFill>
                           <a:latin typeface="Calibri"/>
                         </a:rPr>
-                        <a:t>latent backbone justified</a:t>
+                        <a:t>T2M does not transfer</a:t>
                       </a:r>
                     </a:p>
                   </a:txBody>
@@ -5754,7 +5754,7 @@
                           </a:solidFill>
                           <a:latin typeface="Calibri"/>
                         </a:rPr>
-                        <a:t>Ego→motion regressor</a:t>
+                        <a:t>Raw-space diffusion (MDM-style)</a:t>
                       </a:r>
                     </a:p>
                   </a:txBody>
@@ -5777,7 +5777,7 @@
                           </a:solidFill>
                           <a:latin typeface="Calibri"/>
                         </a:rPr>
-                        <a:t>35.47</a:t>
+                        <a:t>26.43</a:t>
                       </a:r>
                     </a:p>
                   </a:txBody>
@@ -5800,7 +5800,7 @@
                           </a:solidFill>
                           <a:latin typeface="Calibri"/>
                         </a:rPr>
-                        <a:t>L2-optimal, unrealistic</a:t>
+                        <a:t>latent backbone justified</a:t>
                       </a:r>
                     </a:p>
                   </a:txBody>
@@ -5825,13 +5825,84 @@
                           </a:solidFill>
                           <a:latin typeface="Calibri"/>
                         </a:rPr>
+                        <a:t>Ego→motion regressor</a:t>
+                      </a:r>
+                    </a:p>
+                  </a:txBody>
+                  <a:tcPr marL="50800" marT="0" marB="0">
+                    <a:solidFill>
+                      <a:srgbClr val="FFFFFF"/>
+                    </a:solidFill>
+                  </a:tcPr>
+                </a:tc>
+                <a:tc>
+                  <a:txBody>
+                    <a:bodyPr/>
+                    <a:lstStyle/>
+                    <a:p>
+                      <a:pPr algn="ctr"/>
+                      <a:r>
+                        <a:rPr sz="950" b="0" i="0">
+                          <a:solidFill>
+                            <a:srgbClr val="1F2A37"/>
+                          </a:solidFill>
+                          <a:latin typeface="Calibri"/>
+                        </a:rPr>
+                        <a:t>35.47</a:t>
+                      </a:r>
+                    </a:p>
+                  </a:txBody>
+                  <a:tcPr marL="50800" marT="0" marB="0">
+                    <a:solidFill>
+                      <a:srgbClr val="FFFFFF"/>
+                    </a:solidFill>
+                  </a:tcPr>
+                </a:tc>
+                <a:tc>
+                  <a:txBody>
+                    <a:bodyPr/>
+                    <a:lstStyle/>
+                    <a:p>
+                      <a:pPr algn="ctr"/>
+                      <a:r>
+                        <a:rPr sz="950" b="0" i="0">
+                          <a:solidFill>
+                            <a:srgbClr val="1F2A37"/>
+                          </a:solidFill>
+                          <a:latin typeface="Calibri"/>
+                        </a:rPr>
+                        <a:t>L2-optimal, unrealistic</a:t>
+                      </a:r>
+                    </a:p>
+                  </a:txBody>
+                  <a:tcPr marL="50800" marT="0" marB="0">
+                    <a:solidFill>
+                      <a:srgbClr val="FFFFFF"/>
+                    </a:solidFill>
+                  </a:tcPr>
+                </a:tc>
+              </a:tr>
+              <a:tr h="214884">
+                <a:tc>
+                  <a:txBody>
+                    <a:bodyPr/>
+                    <a:lstStyle/>
+                    <a:p>
+                      <a:pPr algn="l"/>
+                      <a:r>
+                        <a:rPr sz="950" b="0" i="0">
+                          <a:solidFill>
+                            <a:srgbClr val="1F2A37"/>
+                          </a:solidFill>
+                          <a:latin typeface="Calibri"/>
+                        </a:rPr>
                         <a:t>Trajectory + static body</a:t>
                       </a:r>
                     </a:p>
                   </a:txBody>
                   <a:tcPr marL="50800" marT="0" marB="0">
                     <a:solidFill>
-                      <a:srgbClr val="FFFFFF"/>
+                      <a:srgbClr val="EFF4FB"/>
                     </a:solidFill>
                   </a:tcPr>
                 </a:tc>
@@ -5854,7 +5925,7 @@
                   </a:txBody>
                   <a:tcPr marL="50800" marT="0" marB="0">
                     <a:solidFill>
-                      <a:srgbClr val="FFFFFF"/>
+                      <a:srgbClr val="EFF4FB"/>
                     </a:solidFill>
                   </a:tcPr>
                 </a:tc>
@@ -5877,7 +5948,7 @@
                   </a:txBody>
                   <a:tcPr marL="50800" marT="0" marB="0">
                     <a:solidFill>
-                      <a:srgbClr val="FFFFFF"/>
+                      <a:srgbClr val="EFF4FB"/>
                     </a:solidFill>
                   </a:tcPr>
                 </a:tc>
@@ -5998,7 +6069,7 @@
                 </a:solidFill>
                 <a:latin typeface="Calibri"/>
               </a:rPr>
-              <a:t>▪  FID — 40% over pooled, non-overlapping CIs, unified eval pipeline.</a:t>
+              <a:t>▪  FID — 40% over pooled (non-overlapping CIs); but a trained prior also reaches 3.24, so FID alone does not credit conditioning.</a:t>
             </a:r>
           </a:p>
           <a:p>
@@ -6177,7 +6248,7 @@
                 </a:solidFill>
                 <a:latin typeface="Calibri"/>
               </a:rPr>
-              <a:t>information ladder — how much conditioning information is actually needed? 0 bits (unconditional) → 2.99 bits (body text) → 6.09 bits (ego text) → continuous 196×2 trajectory (ours). </a:t>
+              <a:t>information ladder — 0 bits (trained unconditional: FID 3.24) → 5.17 bits vehicle-only text (training) → 6.09 bits oracle text incl. GT behaviour (eval pending) → continuous trajectory (2.88). FID compares marginals; conditioning shows in ADE/FDE + behaviour. </a:t>
             </a:r>
             <a:r>
               <a:rPr sz="950" b="1" i="0">

</xml_diff>

<commit_message>
research(results): per-condition controls — trained prior is ego-blind, oracle is told the answer, EgoPed-IA best FID but not best-conditioned
Held-out val_test, K=5, N=1190 (ADE/FDE + behavioral probe):
- trained unconditional: FID 3.24 (= H4) but ADE 2.990 (+29% vs H4 2.320), separation 0.041
- oracle text: ADE 1.899, separation 0.933 (caption leak read back; probe sanity)
- EgoPed-IA: ADE 2.635 / minADE5 1.707 / separation 0.152 / gen stop-rate 0.142 -> worse than
  H4 on every per-condition metric; H4 is the best-CONDITIONED model.
Paper: rows in tab:adefde + tab:behavior, ADE/separation columns in tab:ladder, caption bold-scope
clauses, two paragraphs. eval_ade_fde.py: extra-override hook + MODELS uncond_trained/text_oracle/
ia/ia_ep3399 (epoch-matched diagnostic); behavioral_probe.py skips rungs without dumps.

Co-Authored-By: Claude Fable 5.1 <noreply@anthropic.com>
</commit_message>
<xml_diff>
--- a/research/to_human/EgoPed_onepager.pptx
+++ b/research/to_human/EgoPed_onepager.pptx
@@ -6101,7 +6101,7 @@
                 </a:solidFill>
                 <a:latin typeface="Calibri"/>
               </a:rPr>
-              <a:t>▪  Trajectory ADE/FDE — no learned evaluator: beats pooled on all 4 metrics despite lower R@1 → the R@1 gap is an embedding artifact.</a:t>
+              <a:t>▪  Trajectory ADE/FDE — no learned evaluator: H4 beats pooled on all 4 metrics; a trained prior with the SAME FID is 29% worse (ego-blind) — and EgoPed-IA, best by FID, is worse than H4 per-condition (ADE 2.64 vs 2.32; separation 0.15 vs 0.33): H4 is the best-conditioned model.</a:t>
             </a:r>
           </a:p>
           <a:p>
@@ -6248,7 +6248,7 @@
                 </a:solidFill>
                 <a:latin typeface="Calibri"/>
               </a:rPr>
-              <a:t>information ladder — 0 bits (trained unconditional: FID 3.24) → 5.17 bits vehicle-only text (training) → 6.09 bits oracle text incl. GT behaviour (2.82) → continuous trajectory (H4 3.39 / IA 2.88). FID ranks marginals, not conditioning — see ADE/FDE + behaviour. </a:t>
+              <a:t>information ladder — 0 bits (trained unconditional: FID 3.24) → 5.17 bits vehicle-only text (training) → 6.09 bits oracle text incl. GT behaviour (FID 2.82, ADE 1.90) → trajectory (H4: FID 3.39, ADE 2.32, sep 0.33). FID ranks marginals; ADE + behaviour rank conditioning. </a:t>
             </a:r>
             <a:r>
               <a:rPr sz="950" b="1" i="0">

</xml_diff>

<commit_message>
research(results): information ladder complete — vehicle-only text recovers ~2/3 of the trajectory's per-condition gain at a far worse marginal
Fair rung (5.17 bits), epoch-matched ep3399/CFG10: FID 5.91, ADE 2.516, FDE 5.094,
separation 0.214, Brier 0.183. FID-best checkpoint (ep99/CFG5, FID 5.12) is ego-blind
(separation 0.051, ADE 2.709). Final ladder (FID/ADE/sep): prior 3.24/2.99/0.04 ->
vehicle text 5.91/2.52/0.21 -> oracle 2.82/1.90/0.93 -> trajectory 3.39/2.32/0.33 ->
IA 2.88/2.64/0.15. Paper: tab:ladder row, tab:adefde + tab:behavior rows, paragraph;
one-pager footer; item 10 closed in tracker.

Co-Authored-By: Claude Fable 5.1 <noreply@anthropic.com>
</commit_message>
<xml_diff>
--- a/research/to_human/EgoPed_onepager.pptx
+++ b/research/to_human/EgoPed_onepager.pptx
@@ -6239,7 +6239,7 @@
                 </a:solidFill>
                 <a:latin typeface="Calibri"/>
               </a:rPr>
-              <a:t>IN FLIGHT: </a:t>
+              <a:t>RESULT: </a:t>
             </a:r>
             <a:r>
               <a:rPr sz="950" b="0" i="0">
@@ -6248,7 +6248,7 @@
                 </a:solidFill>
                 <a:latin typeface="Calibri"/>
               </a:rPr>
-              <a:t>information ladder — 0 bits (trained unconditional: FID 3.24) → 5.17 bits vehicle-only text (training) → 6.09 bits oracle text incl. GT behaviour (FID 2.82, ADE 1.90) → trajectory (H4: FID 3.39, ADE 2.32, sep 0.33). FID ranks marginals; ADE + behaviour rank conditioning. </a:t>
+              <a:t>information ladder (FID / ADE / behaviour-separation) — 0 bits: 3.24 / 2.99 / 0.04 → 5-bit vehicle text: 5.91 / 2.52 / 0.21 → oracle text (told the behaviour): 2.82 / 1.90 / 0.93 → trajectory (H4): 3.39 / 2.32 / 0.33. The trajectory recovers 61% of the know-nothing→know-the-outcome ADE gap, vehicle text 43%; FID ranks marginals, not conditioning. </a:t>
             </a:r>
             <a:r>
               <a:rPr sz="950" b="1" i="0">

</xml_diff>